<commit_message>
v2: full-bleed Ink bg + accent line for editable card
</commit_message>
<xml_diff>
--- a/quote-cards/thought-into-gold-editable.pptx
+++ b/quote-cards/thought-into-gold-editable.pptx
@@ -3098,143 +3098,23 @@
       <p:grpSpPr/>
       <p:sp>
         <p:nvSpPr>
-          <p:cNvPr id="2" name="TextBox 1"/>
-          <p:cNvSpPr txBox="1"/>
+          <p:cNvPr id="2" name="Rectangle 1"/>
+          <p:cNvSpPr/>
           <p:nvPr/>
         </p:nvSpPr>
         <p:spPr>
           <a:xfrm>
-            <a:off x="960120" y="777240"/>
-            <a:ext cx="8321040" cy="548640"/>
+            <a:off x="0" y="0"/>
+            <a:ext cx="10287000" cy="10287000"/>
           </a:xfrm>
           <a:prstGeom prst="rect">
             <a:avLst/>
           </a:prstGeom>
-          <a:noFill/>
-        </p:spPr>
-        <p:txBody>
-          <a:bodyPr wrap="square">
-            <a:spAutoFit/>
-          </a:bodyPr>
-          <a:lstStyle/>
-          <a:p>
-            <a:pPr algn="l"/>
-            <a:r>
-              <a:rPr sz="1500" i="0" b="1" spc="300">
-                <a:solidFill>
-                  <a:srgbClr val="10B77F"/>
-                </a:solidFill>
-                <a:latin typeface="Inter"/>
-              </a:rPr>
-              <a:t>AUGMENTED TEAM</a:t>
-            </a:r>
-          </a:p>
-        </p:txBody>
-      </p:sp>
-      <p:sp>
-        <p:nvSpPr>
-          <p:cNvPr id="3" name="TextBox 2"/>
-          <p:cNvSpPr txBox="1"/>
-          <p:nvPr/>
-        </p:nvSpPr>
-        <p:spPr>
-          <a:xfrm>
-            <a:off x="960120" y="3154680"/>
-            <a:ext cx="8412480" cy="3291840"/>
-          </a:xfrm>
-          <a:prstGeom prst="rect">
-            <a:avLst/>
-          </a:prstGeom>
-          <a:noFill/>
-        </p:spPr>
-        <p:txBody>
-          <a:bodyPr wrap="square" anchor="ctr">
-            <a:spAutoFit/>
-          </a:bodyPr>
-          <a:lstStyle/>
-          <a:p>
-            <a:pPr algn="l">
-              <a:lnSpc>
-                <a:spcPct val="106000"/>
-              </a:lnSpc>
-            </a:pPr>
-            <a:r>
-              <a:rPr sz="4700" i="0" b="0">
-                <a:solidFill>
-                  <a:srgbClr val="FEFEFE"/>
-                </a:solidFill>
-                <a:latin typeface="Instrument Serif"/>
-              </a:rPr>
-              <a:t>Not sand </a:t>
-            </a:r>
-            <a:r>
-              <a:rPr sz="4700" i="0" b="0">
-                <a:solidFill>
-                  <a:srgbClr val="C7CAD2"/>
-                </a:solidFill>
-                <a:latin typeface="Instrument Serif"/>
-              </a:rPr>
-              <a:t>into thought.</a:t>
-            </a:r>
-          </a:p>
-          <a:p>
-            <a:pPr algn="l">
-              <a:lnSpc>
-                <a:spcPct val="106000"/>
-              </a:lnSpc>
-            </a:pPr>
-            <a:r>
-              <a:rPr sz="4700" i="0" b="0">
-                <a:solidFill>
-                  <a:srgbClr val="FEFEFE"/>
-                </a:solidFill>
-                <a:latin typeface="Instrument Serif"/>
-              </a:rPr>
-              <a:t>Thought into </a:t>
-            </a:r>
-            <a:r>
-              <a:rPr sz="4700" i="1" b="0">
-                <a:solidFill>
-                  <a:srgbClr val="10B77F"/>
-                </a:solidFill>
-                <a:latin typeface="Instrument Serif"/>
-              </a:rPr>
-              <a:t>gold</a:t>
-            </a:r>
-            <a:r>
-              <a:rPr sz="4700" i="0" b="0">
-                <a:solidFill>
-                  <a:srgbClr val="FEFEFE"/>
-                </a:solidFill>
-                <a:latin typeface="Instrument Serif"/>
-              </a:rPr>
-              <a:t>.</a:t>
-            </a:r>
-          </a:p>
-        </p:txBody>
-      </p:sp>
-      <p:sp>
-        <p:nvSpPr>
-          <p:cNvPr id="4" name="Arc 3"/>
-          <p:cNvSpPr/>
-          <p:nvPr/>
-        </p:nvSpPr>
-        <p:spPr>
-          <a:xfrm>
-            <a:off x="6126480" y="6126480"/>
-            <a:ext cx="5120640" cy="5120640"/>
-          </a:xfrm>
-          <a:prstGeom prst="arc">
-            <a:avLst>
-              <a:gd name="adj1" fmla="val 18000000"/>
-              <a:gd name="adj2" fmla="val 27000000"/>
-            </a:avLst>
-          </a:prstGeom>
-          <a:noFill/>
-          <a:ln w="28575">
-            <a:solidFill>
-              <a:srgbClr val="10B77F"/>
-            </a:solidFill>
+          <a:solidFill>
+            <a:srgbClr val="0C0E18"/>
+          </a:solidFill>
+          <a:ln>
+            <a:noFill/>
           </a:ln>
           <a:effectLst/>
         </p:spPr>
@@ -3257,6 +3137,123 @@
           <a:lstStyle/>
           <a:p>
             <a:pPr algn="ctr"/>
+          </a:p>
+        </p:txBody>
+      </p:sp>
+      <p:sp>
+        <p:nvSpPr>
+          <p:cNvPr id="3" name="TextBox 2"/>
+          <p:cNvSpPr txBox="1"/>
+          <p:nvPr/>
+        </p:nvSpPr>
+        <p:spPr>
+          <a:xfrm>
+            <a:off x="960120" y="777240"/>
+            <a:ext cx="8321040" cy="548640"/>
+          </a:xfrm>
+          <a:prstGeom prst="rect">
+            <a:avLst/>
+          </a:prstGeom>
+          <a:noFill/>
+        </p:spPr>
+        <p:txBody>
+          <a:bodyPr wrap="square">
+            <a:spAutoFit/>
+          </a:bodyPr>
+          <a:lstStyle/>
+          <a:p>
+            <a:pPr algn="l"/>
+            <a:r>
+              <a:rPr sz="1500" i="0" b="1" spc="300">
+                <a:solidFill>
+                  <a:srgbClr val="10B77F"/>
+                </a:solidFill>
+                <a:latin typeface="Inter"/>
+              </a:rPr>
+              <a:t>AUGMENTED TEAM</a:t>
+            </a:r>
+          </a:p>
+        </p:txBody>
+      </p:sp>
+      <p:sp>
+        <p:nvSpPr>
+          <p:cNvPr id="4" name="TextBox 3"/>
+          <p:cNvSpPr txBox="1"/>
+          <p:nvPr/>
+        </p:nvSpPr>
+        <p:spPr>
+          <a:xfrm>
+            <a:off x="960120" y="3154680"/>
+            <a:ext cx="8412480" cy="3291840"/>
+          </a:xfrm>
+          <a:prstGeom prst="rect">
+            <a:avLst/>
+          </a:prstGeom>
+          <a:noFill/>
+        </p:spPr>
+        <p:txBody>
+          <a:bodyPr wrap="square" anchor="ctr">
+            <a:spAutoFit/>
+          </a:bodyPr>
+          <a:lstStyle/>
+          <a:p>
+            <a:pPr algn="l">
+              <a:lnSpc>
+                <a:spcPct val="106000"/>
+              </a:lnSpc>
+            </a:pPr>
+            <a:r>
+              <a:rPr sz="4700" i="0" b="0">
+                <a:solidFill>
+                  <a:srgbClr val="FEFEFE"/>
+                </a:solidFill>
+                <a:latin typeface="Instrument Serif"/>
+              </a:rPr>
+              <a:t>Not sand </a:t>
+            </a:r>
+            <a:r>
+              <a:rPr sz="4700" i="0" b="0">
+                <a:solidFill>
+                  <a:srgbClr val="C7CAD2"/>
+                </a:solidFill>
+                <a:latin typeface="Instrument Serif"/>
+              </a:rPr>
+              <a:t>into thought.</a:t>
+            </a:r>
+          </a:p>
+          <a:p>
+            <a:pPr algn="l">
+              <a:lnSpc>
+                <a:spcPct val="106000"/>
+              </a:lnSpc>
+            </a:pPr>
+            <a:r>
+              <a:rPr sz="4700" i="0" b="0">
+                <a:solidFill>
+                  <a:srgbClr val="FEFEFE"/>
+                </a:solidFill>
+                <a:latin typeface="Instrument Serif"/>
+              </a:rPr>
+              <a:t>Thought into </a:t>
+            </a:r>
+            <a:r>
+              <a:rPr sz="4700" i="1" b="0">
+                <a:solidFill>
+                  <a:srgbClr val="10B77F"/>
+                </a:solidFill>
+                <a:latin typeface="Instrument Serif"/>
+              </a:rPr>
+              <a:t>gold</a:t>
+            </a:r>
+            <a:r>
+              <a:rPr sz="4700" i="0" b="0">
+                <a:solidFill>
+                  <a:srgbClr val="FEFEFE"/>
+                </a:solidFill>
+                <a:latin typeface="Instrument Serif"/>
+              </a:rPr>
+              <a:t>.</a:t>
+            </a:r>
           </a:p>
         </p:txBody>
       </p:sp>
@@ -3336,6 +3333,50 @@
               </a:rPr>
               <a:t>Augmented Team</a:t>
             </a:r>
+          </a:p>
+        </p:txBody>
+      </p:sp>
+      <p:sp>
+        <p:nvSpPr>
+          <p:cNvPr id="7" name="Rectangle 6"/>
+          <p:cNvSpPr/>
+          <p:nvPr/>
+        </p:nvSpPr>
+        <p:spPr>
+          <a:xfrm>
+            <a:off x="3703320" y="9253728"/>
+            <a:ext cx="5623560" cy="20116"/>
+          </a:xfrm>
+          <a:prstGeom prst="rect">
+            <a:avLst/>
+          </a:prstGeom>
+          <a:solidFill>
+            <a:srgbClr val="10B77F"/>
+          </a:solidFill>
+          <a:ln>
+            <a:noFill/>
+          </a:ln>
+          <a:effectLst/>
+        </p:spPr>
+        <p:style>
+          <a:lnRef idx="1">
+            <a:schemeClr val="accent1"/>
+          </a:lnRef>
+          <a:fillRef idx="3">
+            <a:schemeClr val="accent1"/>
+          </a:fillRef>
+          <a:effectRef idx="2">
+            <a:schemeClr val="accent1"/>
+          </a:effectRef>
+          <a:fontRef idx="minor">
+            <a:schemeClr val="lt1"/>
+          </a:fontRef>
+        </p:style>
+        <p:txBody>
+          <a:bodyPr rtlCol="0" anchor="ctr"/>
+          <a:lstStyle/>
+          <a:p>
+            <a:pPr algn="ctr"/>
           </a:p>
         </p:txBody>
       </p:sp>

</xml_diff>